<commit_message>
Final commit before 0.6.0
</commit_message>
<xml_diff>
--- a/tuts/prezzo/antupy_diagram.pptx
+++ b/tuts/prezzo/antupy_diagram.pptx
@@ -416,7 +416,7 @@
           <a:p>
             <a:fld id="{0F545F80-4238-44B2-8FA4-030309B17934}" type="datetimeFigureOut">
               <a:rPr lang="en-IE" smtClean="0"/>
-              <a:t>16/04/2026</a:t>
+              <a:t>13/05/2026</a:t>
             </a:fld>
             <a:endParaRPr lang="en-IE"/>
           </a:p>
@@ -616,7 +616,7 @@
           <a:p>
             <a:fld id="{0F545F80-4238-44B2-8FA4-030309B17934}" type="datetimeFigureOut">
               <a:rPr lang="en-IE" smtClean="0"/>
-              <a:t>16/04/2026</a:t>
+              <a:t>13/05/2026</a:t>
             </a:fld>
             <a:endParaRPr lang="en-IE"/>
           </a:p>
@@ -826,7 +826,7 @@
           <a:p>
             <a:fld id="{0F545F80-4238-44B2-8FA4-030309B17934}" type="datetimeFigureOut">
               <a:rPr lang="en-IE" smtClean="0"/>
-              <a:t>16/04/2026</a:t>
+              <a:t>13/05/2026</a:t>
             </a:fld>
             <a:endParaRPr lang="en-IE"/>
           </a:p>
@@ -1026,7 +1026,7 @@
           <a:p>
             <a:fld id="{0F545F80-4238-44B2-8FA4-030309B17934}" type="datetimeFigureOut">
               <a:rPr lang="en-IE" smtClean="0"/>
-              <a:t>16/04/2026</a:t>
+              <a:t>13/05/2026</a:t>
             </a:fld>
             <a:endParaRPr lang="en-IE"/>
           </a:p>
@@ -1302,7 +1302,7 @@
           <a:p>
             <a:fld id="{0F545F80-4238-44B2-8FA4-030309B17934}" type="datetimeFigureOut">
               <a:rPr lang="en-IE" smtClean="0"/>
-              <a:t>16/04/2026</a:t>
+              <a:t>13/05/2026</a:t>
             </a:fld>
             <a:endParaRPr lang="en-IE"/>
           </a:p>
@@ -1570,7 +1570,7 @@
           <a:p>
             <a:fld id="{0F545F80-4238-44B2-8FA4-030309B17934}" type="datetimeFigureOut">
               <a:rPr lang="en-IE" smtClean="0"/>
-              <a:t>16/04/2026</a:t>
+              <a:t>13/05/2026</a:t>
             </a:fld>
             <a:endParaRPr lang="en-IE"/>
           </a:p>
@@ -1985,7 +1985,7 @@
           <a:p>
             <a:fld id="{0F545F80-4238-44B2-8FA4-030309B17934}" type="datetimeFigureOut">
               <a:rPr lang="en-IE" smtClean="0"/>
-              <a:t>16/04/2026</a:t>
+              <a:t>13/05/2026</a:t>
             </a:fld>
             <a:endParaRPr lang="en-IE"/>
           </a:p>
@@ -2127,7 +2127,7 @@
           <a:p>
             <a:fld id="{0F545F80-4238-44B2-8FA4-030309B17934}" type="datetimeFigureOut">
               <a:rPr lang="en-IE" smtClean="0"/>
-              <a:t>16/04/2026</a:t>
+              <a:t>13/05/2026</a:t>
             </a:fld>
             <a:endParaRPr lang="en-IE"/>
           </a:p>
@@ -2240,7 +2240,7 @@
           <a:p>
             <a:fld id="{0F545F80-4238-44B2-8FA4-030309B17934}" type="datetimeFigureOut">
               <a:rPr lang="en-IE" smtClean="0"/>
-              <a:t>16/04/2026</a:t>
+              <a:t>13/05/2026</a:t>
             </a:fld>
             <a:endParaRPr lang="en-IE"/>
           </a:p>
@@ -2553,7 +2553,7 @@
           <a:p>
             <a:fld id="{0F545F80-4238-44B2-8FA4-030309B17934}" type="datetimeFigureOut">
               <a:rPr lang="en-IE" smtClean="0"/>
-              <a:t>16/04/2026</a:t>
+              <a:t>13/05/2026</a:t>
             </a:fld>
             <a:endParaRPr lang="en-IE"/>
           </a:p>
@@ -2842,7 +2842,7 @@
           <a:p>
             <a:fld id="{0F545F80-4238-44B2-8FA4-030309B17934}" type="datetimeFigureOut">
               <a:rPr lang="en-IE" smtClean="0"/>
-              <a:t>16/04/2026</a:t>
+              <a:t>13/05/2026</a:t>
             </a:fld>
             <a:endParaRPr lang="en-IE"/>
           </a:p>
@@ -3085,7 +3085,7 @@
           <a:p>
             <a:fld id="{0F545F80-4238-44B2-8FA4-030309B17934}" type="datetimeFigureOut">
               <a:rPr lang="en-IE" smtClean="0"/>
-              <a:t>16/04/2026</a:t>
+              <a:t>13/05/2026</a:t>
             </a:fld>
             <a:endParaRPr lang="en-IE"/>
           </a:p>
@@ -3526,17 +3526,19 @@
         </p:nvSpPr>
         <p:spPr>
           <a:xfrm>
-            <a:off x="1789355" y="290634"/>
+            <a:off x="1316253" y="614061"/>
             <a:ext cx="3352800" cy="1325563"/>
           </a:xfrm>
         </p:spPr>
         <p:txBody>
-          <a:bodyPr/>
+          <a:bodyPr>
+            <a:normAutofit/>
+          </a:bodyPr>
           <a:lstStyle/>
           <a:p>
             <a:r>
-              <a:rPr lang="en-IE" noProof="1"/>
-              <a:t>phd code</a:t>
+              <a:rPr lang="en-IE" sz="3200" noProof="1"/>
+              <a:t>phd</a:t>
             </a:r>
           </a:p>
         </p:txBody>
@@ -3557,7 +3559,7 @@
         </p:nvSpPr>
         <p:spPr>
           <a:xfrm>
-            <a:off x="6939205" y="341096"/>
+            <a:off x="3646483" y="587314"/>
             <a:ext cx="4457700" cy="1325563"/>
           </a:xfrm>
           <a:prstGeom prst="rect">
@@ -3589,7 +3591,7 @@
           </a:lstStyle>
           <a:p>
             <a:r>
-              <a:rPr lang="en-IE" noProof="1"/>
+              <a:rPr lang="en-IE" sz="3200" noProof="1"/>
               <a:t>postdoc_1</a:t>
             </a:r>
           </a:p>
@@ -3609,8 +3611,8 @@
         </p:nvGrpSpPr>
         <p:grpSpPr>
           <a:xfrm>
-            <a:off x="1167055" y="1585867"/>
-            <a:ext cx="3975100" cy="5053088"/>
+            <a:off x="353426" y="1508299"/>
+            <a:ext cx="2746577" cy="5053088"/>
             <a:chOff x="893056" y="1614489"/>
             <a:chExt cx="1928938" cy="5053088"/>
           </a:xfrm>
@@ -3678,7 +3680,7 @@
           </p:nvSpPr>
           <p:spPr>
             <a:xfrm>
-              <a:off x="950949" y="5547392"/>
+              <a:off x="950949" y="5437867"/>
               <a:ext cx="1761893" cy="501805"/>
             </a:xfrm>
             <a:prstGeom prst="roundRect">
@@ -3761,7 +3763,7 @@
                     <a:schemeClr val="accent2"/>
                   </a:solidFill>
                 </a:rPr>
-                <a:t>thermal analysis (particle receiver)</a:t>
+                <a:t>thermal analysis</a:t>
               </a:r>
             </a:p>
           </p:txBody>
@@ -3812,7 +3814,7 @@
                     <a:schemeClr val="accent2"/>
                   </a:solidFill>
                 </a:rPr>
-                <a:t>power generation (dispatch)</a:t>
+                <a:t>power generation</a:t>
               </a:r>
             </a:p>
           </p:txBody>
@@ -3863,7 +3865,7 @@
                     <a:schemeClr val="accent2"/>
                   </a:solidFill>
                 </a:rPr>
-                <a:t>optical analysis (beam down)</a:t>
+                <a:t>optical analysis</a:t>
               </a:r>
             </a:p>
           </p:txBody>
@@ -3882,7 +3884,7 @@
           </p:nvSpPr>
           <p:spPr>
             <a:xfrm>
-              <a:off x="950950" y="6094183"/>
+              <a:off x="950949" y="6015851"/>
               <a:ext cx="1761894" cy="501805"/>
             </a:xfrm>
             <a:prstGeom prst="roundRect">
@@ -4036,8 +4038,8 @@
         </p:nvGrpSpPr>
         <p:grpSpPr>
           <a:xfrm>
-            <a:off x="6680201" y="1585867"/>
-            <a:ext cx="3975100" cy="5053088"/>
+            <a:off x="3265893" y="1520647"/>
+            <a:ext cx="2931565" cy="5053088"/>
             <a:chOff x="893056" y="1614489"/>
             <a:chExt cx="1928938" cy="5053088"/>
           </a:xfrm>
@@ -4105,8 +4107,8 @@
           </p:nvSpPr>
           <p:spPr>
             <a:xfrm>
-              <a:off x="950949" y="5547392"/>
-              <a:ext cx="1761893" cy="501805"/>
+              <a:off x="950947" y="5348747"/>
+              <a:ext cx="1761893" cy="291270"/>
             </a:xfrm>
             <a:prstGeom prst="roundRect">
               <a:avLst/>
@@ -4156,7 +4158,7 @@
           </p:nvSpPr>
           <p:spPr>
             <a:xfrm>
-              <a:off x="950949" y="4040436"/>
+              <a:off x="950949" y="3959437"/>
               <a:ext cx="1761893" cy="501805"/>
             </a:xfrm>
             <a:prstGeom prst="roundRect">
@@ -4188,7 +4190,7 @@
                     <a:schemeClr val="accent2"/>
                   </a:solidFill>
                 </a:rPr>
-                <a:t>thermal analysis (particle receiver)</a:t>
+                <a:t>pv simulation</a:t>
               </a:r>
             </a:p>
           </p:txBody>
@@ -4207,7 +4209,7 @@
           </p:nvSpPr>
           <p:spPr>
             <a:xfrm>
-              <a:off x="950949" y="4618257"/>
+              <a:off x="950948" y="4561581"/>
               <a:ext cx="1761894" cy="501805"/>
             </a:xfrm>
             <a:prstGeom prst="roundRect">
@@ -4239,7 +4241,7 @@
                     <a:schemeClr val="accent2"/>
                   </a:solidFill>
                 </a:rPr>
-                <a:t>power generation (dispatch)</a:t>
+                <a:t>financial calculations</a:t>
               </a:r>
             </a:p>
           </p:txBody>
@@ -4258,7 +4260,7 @@
           </p:nvSpPr>
           <p:spPr>
             <a:xfrm>
-              <a:off x="950949" y="3480344"/>
+              <a:off x="950949" y="3358531"/>
               <a:ext cx="1761893" cy="501805"/>
             </a:xfrm>
             <a:prstGeom prst="roundRect">
@@ -4290,7 +4292,7 @@
                     <a:schemeClr val="accent2"/>
                   </a:solidFill>
                 </a:rPr>
-                <a:t>optical analysis (beam down)</a:t>
+                <a:t>dewh simulation</a:t>
               </a:r>
             </a:p>
           </p:txBody>
@@ -4309,8 +4311,8 @@
           </p:nvSpPr>
           <p:spPr>
             <a:xfrm>
-              <a:off x="950950" y="6094183"/>
-              <a:ext cx="1761894" cy="501805"/>
+              <a:off x="950947" y="5757594"/>
+              <a:ext cx="1761894" cy="295824"/>
             </a:xfrm>
             <a:prstGeom prst="roundRect">
               <a:avLst/>
@@ -4449,6 +4451,436 @@
           </p:txBody>
         </p:sp>
       </p:grpSp>
+      <p:sp>
+        <p:nvSpPr>
+          <p:cNvPr id="4" name="Rectangle: Rounded Corners 3">
+            <a:extLst>
+              <a:ext uri="{FF2B5EF4-FFF2-40B4-BE49-F238E27FC236}">
+                <a16:creationId xmlns:a16="http://schemas.microsoft.com/office/drawing/2014/main" id="{44A87002-F9E8-BE4D-F44A-BD59132DBA16}"/>
+              </a:ext>
+            </a:extLst>
+          </p:cNvPr>
+          <p:cNvSpPr/>
+          <p:nvPr/>
+        </p:nvSpPr>
+        <p:spPr>
+          <a:xfrm>
+            <a:off x="3353875" y="6043647"/>
+            <a:ext cx="2677695" cy="322419"/>
+          </a:xfrm>
+          <a:prstGeom prst="roundRect">
+            <a:avLst/>
+          </a:prstGeom>
+        </p:spPr>
+        <p:style>
+          <a:lnRef idx="2">
+            <a:schemeClr val="accent5"/>
+          </a:lnRef>
+          <a:fillRef idx="1">
+            <a:schemeClr val="lt1"/>
+          </a:fillRef>
+          <a:effectRef idx="0">
+            <a:schemeClr val="accent5"/>
+          </a:effectRef>
+          <a:fontRef idx="minor">
+            <a:schemeClr val="dk1"/>
+          </a:fontRef>
+        </p:style>
+        <p:txBody>
+          <a:bodyPr rtlCol="0" anchor="ctr"/>
+          <a:lstStyle/>
+          <a:p>
+            <a:pPr algn="ctr"/>
+            <a:r>
+              <a:rPr lang="en-IE" noProof="1">
+                <a:solidFill>
+                  <a:schemeClr val="accent5"/>
+                </a:solidFill>
+              </a:rPr>
+              <a:t>hwd data</a:t>
+            </a:r>
+          </a:p>
+        </p:txBody>
+      </p:sp>
+      <p:grpSp>
+        <p:nvGrpSpPr>
+          <p:cNvPr id="5" name="Group 4">
+            <a:extLst>
+              <a:ext uri="{FF2B5EF4-FFF2-40B4-BE49-F238E27FC236}">
+                <a16:creationId xmlns:a16="http://schemas.microsoft.com/office/drawing/2014/main" id="{B1385FB5-7E21-FA4D-60FE-E23EB44D28D5}"/>
+              </a:ext>
+            </a:extLst>
+          </p:cNvPr>
+          <p:cNvGrpSpPr/>
+          <p:nvPr/>
+        </p:nvGrpSpPr>
+        <p:grpSpPr>
+          <a:xfrm>
+            <a:off x="6407233" y="1563449"/>
+            <a:ext cx="2416727" cy="4202035"/>
+            <a:chOff x="6301662" y="1576465"/>
+            <a:chExt cx="2416727" cy="4202035"/>
+          </a:xfrm>
+        </p:grpSpPr>
+        <p:sp>
+          <p:nvSpPr>
+            <p:cNvPr id="6" name="Rectangle: Rounded Corners 5">
+              <a:extLst>
+                <a:ext uri="{FF2B5EF4-FFF2-40B4-BE49-F238E27FC236}">
+                  <a16:creationId xmlns:a16="http://schemas.microsoft.com/office/drawing/2014/main" id="{3B8C9ACB-DBFF-DFCE-7D98-ECC148DC4474}"/>
+                </a:ext>
+              </a:extLst>
+            </p:cNvPr>
+            <p:cNvSpPr/>
+            <p:nvPr/>
+          </p:nvSpPr>
+          <p:spPr>
+            <a:xfrm>
+              <a:off x="6301662" y="1576465"/>
+              <a:ext cx="2416727" cy="4202035"/>
+            </a:xfrm>
+            <a:prstGeom prst="roundRect">
+              <a:avLst>
+                <a:gd name="adj" fmla="val 9304"/>
+              </a:avLst>
+            </a:prstGeom>
+          </p:spPr>
+          <p:style>
+            <a:lnRef idx="2">
+              <a:schemeClr val="accent1"/>
+            </a:lnRef>
+            <a:fillRef idx="1">
+              <a:schemeClr val="lt1"/>
+            </a:fillRef>
+            <a:effectRef idx="0">
+              <a:schemeClr val="accent1"/>
+            </a:effectRef>
+            <a:fontRef idx="minor">
+              <a:schemeClr val="dk1"/>
+            </a:fontRef>
+          </p:style>
+          <p:txBody>
+            <a:bodyPr rtlCol="0" anchor="t"/>
+            <a:lstStyle/>
+            <a:p>
+              <a:pPr algn="ctr"/>
+              <a:r>
+                <a:rPr lang="en-IE" noProof="1"/>
+                <a:t>MED-Solar</a:t>
+              </a:r>
+            </a:p>
+          </p:txBody>
+        </p:sp>
+        <p:sp>
+          <p:nvSpPr>
+            <p:cNvPr id="7" name="Rectangle: Rounded Corners 6">
+              <a:extLst>
+                <a:ext uri="{FF2B5EF4-FFF2-40B4-BE49-F238E27FC236}">
+                  <a16:creationId xmlns:a16="http://schemas.microsoft.com/office/drawing/2014/main" id="{B21C0B24-4EE3-9A40-6B9F-7FE1316681BA}"/>
+                </a:ext>
+              </a:extLst>
+            </p:cNvPr>
+            <p:cNvSpPr/>
+            <p:nvPr/>
+          </p:nvSpPr>
+          <p:spPr>
+            <a:xfrm>
+              <a:off x="6634401" y="2126670"/>
+              <a:ext cx="1761893" cy="501805"/>
+            </a:xfrm>
+            <a:prstGeom prst="roundRect">
+              <a:avLst/>
+            </a:prstGeom>
+          </p:spPr>
+          <p:style>
+            <a:lnRef idx="2">
+              <a:schemeClr val="accent1"/>
+            </a:lnRef>
+            <a:fillRef idx="1">
+              <a:schemeClr val="lt1"/>
+            </a:fillRef>
+            <a:effectRef idx="0">
+              <a:schemeClr val="accent1"/>
+            </a:effectRef>
+            <a:fontRef idx="minor">
+              <a:schemeClr val="dk1"/>
+            </a:fontRef>
+          </p:style>
+          <p:txBody>
+            <a:bodyPr rtlCol="0" anchor="ctr"/>
+            <a:lstStyle/>
+            <a:p>
+              <a:pPr algn="ctr"/>
+              <a:r>
+                <a:rPr lang="en-IE" noProof="1">
+                  <a:solidFill>
+                    <a:schemeClr val="accent1"/>
+                  </a:solidFill>
+                </a:rPr>
+                <a:t>settings</a:t>
+              </a:r>
+            </a:p>
+          </p:txBody>
+        </p:sp>
+        <p:sp>
+          <p:nvSpPr>
+            <p:cNvPr id="9" name="Rectangle: Rounded Corners 8">
+              <a:extLst>
+                <a:ext uri="{FF2B5EF4-FFF2-40B4-BE49-F238E27FC236}">
+                  <a16:creationId xmlns:a16="http://schemas.microsoft.com/office/drawing/2014/main" id="{F0271F9D-6116-C87D-C5A0-BD4DBCF4EEA5}"/>
+                </a:ext>
+              </a:extLst>
+            </p:cNvPr>
+            <p:cNvSpPr/>
+            <p:nvPr/>
+          </p:nvSpPr>
+          <p:spPr>
+            <a:xfrm>
+              <a:off x="6634396" y="2714909"/>
+              <a:ext cx="1761893" cy="501805"/>
+            </a:xfrm>
+            <a:prstGeom prst="roundRect">
+              <a:avLst/>
+            </a:prstGeom>
+          </p:spPr>
+          <p:style>
+            <a:lnRef idx="2">
+              <a:schemeClr val="accent1"/>
+            </a:lnRef>
+            <a:fillRef idx="1">
+              <a:schemeClr val="lt1"/>
+            </a:fillRef>
+            <a:effectRef idx="0">
+              <a:schemeClr val="accent1"/>
+            </a:effectRef>
+            <a:fontRef idx="minor">
+              <a:schemeClr val="dk1"/>
+            </a:fontRef>
+          </p:style>
+          <p:txBody>
+            <a:bodyPr rtlCol="0" anchor="ctr"/>
+            <a:lstStyle/>
+            <a:p>
+              <a:pPr algn="ctr"/>
+              <a:r>
+                <a:rPr lang="en-IE" noProof="1">
+                  <a:solidFill>
+                    <a:schemeClr val="accent1"/>
+                  </a:solidFill>
+                </a:rPr>
+                <a:t>location</a:t>
+              </a:r>
+            </a:p>
+          </p:txBody>
+        </p:sp>
+        <p:sp>
+          <p:nvSpPr>
+            <p:cNvPr id="10" name="Rectangle: Rounded Corners 9">
+              <a:extLst>
+                <a:ext uri="{FF2B5EF4-FFF2-40B4-BE49-F238E27FC236}">
+                  <a16:creationId xmlns:a16="http://schemas.microsoft.com/office/drawing/2014/main" id="{2C082905-0EB3-C87A-7185-B0A52D967651}"/>
+                </a:ext>
+              </a:extLst>
+            </p:cNvPr>
+            <p:cNvSpPr/>
+            <p:nvPr/>
+          </p:nvSpPr>
+          <p:spPr>
+            <a:xfrm>
+              <a:off x="6631291" y="3338391"/>
+              <a:ext cx="1761893" cy="501805"/>
+            </a:xfrm>
+            <a:prstGeom prst="roundRect">
+              <a:avLst/>
+            </a:prstGeom>
+          </p:spPr>
+          <p:style>
+            <a:lnRef idx="2">
+              <a:schemeClr val="accent2"/>
+            </a:lnRef>
+            <a:fillRef idx="1">
+              <a:schemeClr val="lt1"/>
+            </a:fillRef>
+            <a:effectRef idx="0">
+              <a:schemeClr val="accent2"/>
+            </a:effectRef>
+            <a:fontRef idx="minor">
+              <a:schemeClr val="dk1"/>
+            </a:fontRef>
+          </p:style>
+          <p:txBody>
+            <a:bodyPr rtlCol="0" anchor="ctr"/>
+            <a:lstStyle/>
+            <a:p>
+              <a:pPr algn="ctr"/>
+              <a:r>
+                <a:rPr lang="en-IE" noProof="1">
+                  <a:solidFill>
+                    <a:schemeClr val="accent2"/>
+                  </a:solidFill>
+                </a:rPr>
+                <a:t>PTC</a:t>
+              </a:r>
+            </a:p>
+          </p:txBody>
+        </p:sp>
+        <p:sp>
+          <p:nvSpPr>
+            <p:cNvPr id="14" name="Rectangle: Rounded Corners 13">
+              <a:extLst>
+                <a:ext uri="{FF2B5EF4-FFF2-40B4-BE49-F238E27FC236}">
+                  <a16:creationId xmlns:a16="http://schemas.microsoft.com/office/drawing/2014/main" id="{5698E974-DE34-6B23-3D12-3D9BFDF5799B}"/>
+                </a:ext>
+              </a:extLst>
+            </p:cNvPr>
+            <p:cNvSpPr/>
+            <p:nvPr/>
+          </p:nvSpPr>
+          <p:spPr>
+            <a:xfrm>
+              <a:off x="6631291" y="3951375"/>
+              <a:ext cx="1761893" cy="501805"/>
+            </a:xfrm>
+            <a:prstGeom prst="roundRect">
+              <a:avLst/>
+            </a:prstGeom>
+          </p:spPr>
+          <p:style>
+            <a:lnRef idx="2">
+              <a:schemeClr val="accent2"/>
+            </a:lnRef>
+            <a:fillRef idx="1">
+              <a:schemeClr val="lt1"/>
+            </a:fillRef>
+            <a:effectRef idx="0">
+              <a:schemeClr val="accent2"/>
+            </a:effectRef>
+            <a:fontRef idx="minor">
+              <a:schemeClr val="dk1"/>
+            </a:fontRef>
+          </p:style>
+          <p:txBody>
+            <a:bodyPr rtlCol="0" anchor="ctr"/>
+            <a:lstStyle/>
+            <a:p>
+              <a:pPr algn="ctr"/>
+              <a:r>
+                <a:rPr lang="en-IE" noProof="1">
+                  <a:solidFill>
+                    <a:schemeClr val="accent2"/>
+                  </a:solidFill>
+                </a:rPr>
+                <a:t>MED</a:t>
+              </a:r>
+            </a:p>
+          </p:txBody>
+        </p:sp>
+        <p:sp>
+          <p:nvSpPr>
+            <p:cNvPr id="28" name="Rectangle: Rounded Corners 27">
+              <a:extLst>
+                <a:ext uri="{FF2B5EF4-FFF2-40B4-BE49-F238E27FC236}">
+                  <a16:creationId xmlns:a16="http://schemas.microsoft.com/office/drawing/2014/main" id="{6D547355-8E2C-D9BF-C1B5-4695D121E427}"/>
+                </a:ext>
+              </a:extLst>
+            </p:cNvPr>
+            <p:cNvSpPr/>
+            <p:nvPr/>
+          </p:nvSpPr>
+          <p:spPr>
+            <a:xfrm>
+              <a:off x="6631291" y="4560652"/>
+              <a:ext cx="1761893" cy="501805"/>
+            </a:xfrm>
+            <a:prstGeom prst="roundRect">
+              <a:avLst/>
+            </a:prstGeom>
+          </p:spPr>
+          <p:style>
+            <a:lnRef idx="2">
+              <a:schemeClr val="accent5"/>
+            </a:lnRef>
+            <a:fillRef idx="1">
+              <a:schemeClr val="lt1"/>
+            </a:fillRef>
+            <a:effectRef idx="0">
+              <a:schemeClr val="accent5"/>
+            </a:effectRef>
+            <a:fontRef idx="minor">
+              <a:schemeClr val="dk1"/>
+            </a:fontRef>
+          </p:style>
+          <p:txBody>
+            <a:bodyPr rtlCol="0" anchor="ctr"/>
+            <a:lstStyle/>
+            <a:p>
+              <a:pPr algn="ctr"/>
+              <a:r>
+                <a:rPr lang="en-IE" noProof="1">
+                  <a:solidFill>
+                    <a:schemeClr val="accent5"/>
+                  </a:solidFill>
+                </a:rPr>
+                <a:t>weather</a:t>
+              </a:r>
+            </a:p>
+          </p:txBody>
+        </p:sp>
+      </p:grpSp>
+      <p:sp>
+        <p:nvSpPr>
+          <p:cNvPr id="30" name="Title 1">
+            <a:extLst>
+              <a:ext uri="{FF2B5EF4-FFF2-40B4-BE49-F238E27FC236}">
+                <a16:creationId xmlns:a16="http://schemas.microsoft.com/office/drawing/2014/main" id="{D5A7CEB4-D68B-3150-9664-1D2F7C2D4144}"/>
+              </a:ext>
+            </a:extLst>
+          </p:cNvPr>
+          <p:cNvSpPr txBox="1">
+            <a:spLocks/>
+          </p:cNvSpPr>
+          <p:nvPr/>
+        </p:nvSpPr>
+        <p:spPr>
+          <a:xfrm>
+            <a:off x="6926131" y="604857"/>
+            <a:ext cx="4457700" cy="1325563"/>
+          </a:xfrm>
+          <a:prstGeom prst="rect">
+            <a:avLst/>
+          </a:prstGeom>
+        </p:spPr>
+        <p:txBody>
+          <a:bodyPr vert="horz" lIns="91440" tIns="45720" rIns="91440" bIns="45720" rtlCol="0" anchor="ctr">
+            <a:normAutofit/>
+          </a:bodyPr>
+          <a:lstStyle>
+            <a:lvl1pPr algn="l" defTabSz="914400" rtl="0" eaLnBrk="1" latinLnBrk="0" hangingPunct="1">
+              <a:lnSpc>
+                <a:spcPct val="90000"/>
+              </a:lnSpc>
+              <a:spcBef>
+                <a:spcPct val="0"/>
+              </a:spcBef>
+              <a:buNone/>
+              <a:defRPr sz="4400" kern="1200">
+                <a:solidFill>
+                  <a:schemeClr val="tx1"/>
+                </a:solidFill>
+                <a:latin typeface="+mj-lt"/>
+                <a:ea typeface="+mj-ea"/>
+                <a:cs typeface="+mj-cs"/>
+              </a:defRPr>
+            </a:lvl1pPr>
+          </a:lstStyle>
+          <a:p>
+            <a:r>
+              <a:rPr lang="en-IE" sz="3200" noProof="1"/>
+              <a:t>master</a:t>
+            </a:r>
+          </a:p>
+        </p:txBody>
+      </p:sp>
     </p:spTree>
     <p:extLst>
       <p:ext uri="{BB962C8B-B14F-4D97-AF65-F5344CB8AC3E}">

</xml_diff>